<commit_message>
Regenerative single image: headline and small line only, questions move to the caption
Co-Authored-By: Claude Opus 5.5 <noreply@anthropic.com>
Claude-Session: https://claude.ai/code/session_01Mm2WQWuqhG5pSCHMfFzovJ
</commit_message>
<xml_diff>
--- a/social/regenerative-2026-10-15/single-1/regenerative-single-1-canva.pptx
+++ b/social/regenerative-2026-10-15/single-1/regenerative-single-1-canva.pptx
@@ -3128,8 +3128,8 @@
         </p:blipFill>
         <p:spPr>
           <a:xfrm>
-            <a:off x="7433733" y="338667"/>
-            <a:ext cx="1100667" cy="956733"/>
+            <a:off x="7264400" y="474133"/>
+            <a:ext cx="1270000" cy="1100667"/>
           </a:xfrm>
           <a:prstGeom prst="rect">
             <a:avLst/>
@@ -3138,7 +3138,7 @@
       </p:pic>
       <p:pic>
         <p:nvPicPr>
-          <p:cNvPr id="4" name="rule-1" descr="s1-06-rule-1.png"/>
+          <p:cNvPr id="4" name="soil-strip" descr="s1-05-soil-strip.png"/>
           <p:cNvPicPr>
             <a:picLocks noChangeAspect="1"/>
           </p:cNvPicPr>
@@ -3152,8 +3152,8 @@
         </p:blipFill>
         <p:spPr>
           <a:xfrm>
-            <a:off x="609600" y="4758267"/>
-            <a:ext cx="7924800" cy="25400"/>
+            <a:off x="0" y="8551333"/>
+            <a:ext cx="9144000" cy="2878667"/>
           </a:xfrm>
           <a:prstGeom prst="rect">
             <a:avLst/>
@@ -3162,31 +3162,7 @@
       </p:pic>
       <p:pic>
         <p:nvPicPr>
-          <p:cNvPr id="5" name="rule-2" descr="s1-06-rule-1.png"/>
-          <p:cNvPicPr>
-            <a:picLocks noChangeAspect="1"/>
-          </p:cNvPicPr>
-          <p:nvPr/>
-        </p:nvPicPr>
-        <p:blipFill>
-          <a:blip r:embed="rId4"/>
-          <a:stretch>
-            <a:fillRect/>
-          </a:stretch>
-        </p:blipFill>
-        <p:spPr>
-          <a:xfrm>
-            <a:off x="609600" y="5994400"/>
-            <a:ext cx="7924800" cy="25400"/>
-          </a:xfrm>
-          <a:prstGeom prst="rect">
-            <a:avLst/>
-          </a:prstGeom>
-        </p:spPr>
-      </p:pic>
-      <p:pic>
-        <p:nvPicPr>
-          <p:cNvPr id="6" name="soil-strip" descr="s1-11-soil-strip.png"/>
+          <p:cNvPr id="5" name="mushrooms" descr="s1-06-mushrooms.png"/>
           <p:cNvPicPr>
             <a:picLocks noChangeAspect="1"/>
           </p:cNvPicPr>
@@ -3200,8 +3176,8 @@
         </p:blipFill>
         <p:spPr>
           <a:xfrm>
-            <a:off x="0" y="9144000"/>
-            <a:ext cx="9144000" cy="2286000"/>
+            <a:off x="1439333" y="6350000"/>
+            <a:ext cx="2201333" cy="2709333"/>
           </a:xfrm>
           <a:prstGeom prst="rect">
             <a:avLst/>
@@ -3210,7 +3186,7 @@
       </p:pic>
       <p:pic>
         <p:nvPicPr>
-          <p:cNvPr id="7" name="fern-fiddlehead" descr="s1-12-fern-fiddlehead.png"/>
+          <p:cNvPr id="6" name="fern-fiddlehead" descr="s1-07-fern-fiddlehead.png"/>
           <p:cNvPicPr>
             <a:picLocks noChangeAspect="1"/>
           </p:cNvPicPr>
@@ -3224,8 +3200,8 @@
         </p:blipFill>
         <p:spPr>
           <a:xfrm>
-            <a:off x="7112000" y="7687733"/>
-            <a:ext cx="1693333" cy="1888067"/>
+            <a:off x="4064000" y="6417733"/>
+            <a:ext cx="2370667" cy="2641600"/>
           </a:xfrm>
           <a:prstGeom prst="rect">
             <a:avLst/>
@@ -3234,7 +3210,7 @@
       </p:pic>
       <p:pic>
         <p:nvPicPr>
-          <p:cNvPr id="8" name="mushrooms" descr="s1-13-mushrooms.png"/>
+          <p:cNvPr id="7" name="moss" descr="s1-08-moss.png"/>
           <p:cNvPicPr>
             <a:picLocks noChangeAspect="1"/>
           </p:cNvPicPr>
@@ -3248,8 +3224,8 @@
         </p:blipFill>
         <p:spPr>
           <a:xfrm>
-            <a:off x="5842000" y="7687733"/>
-            <a:ext cx="1524000" cy="1879600"/>
+            <a:off x="6265333" y="7433733"/>
+            <a:ext cx="2370667" cy="1634067"/>
           </a:xfrm>
           <a:prstGeom prst="rect">
             <a:avLst/>
@@ -3258,14 +3234,14 @@
       </p:pic>
       <p:sp>
         <p:nvSpPr>
-          <p:cNvPr id="9" name="headline"/>
+          <p:cNvPr id="8" name="headline"/>
           <p:cNvSpPr txBox="1"/>
           <p:nvPr/>
         </p:nvSpPr>
         <p:spPr>
           <a:xfrm>
-            <a:off x="609600" y="1016000"/>
-            <a:ext cx="7924800" cy="2201333"/>
+            <a:off x="609600" y="1947333"/>
+            <a:ext cx="7924800" cy="2878667"/>
           </a:xfrm>
           <a:prstGeom prst="rect">
             <a:avLst/>
@@ -3280,11 +3256,11 @@
           <a:p>
             <a:pPr algn="l">
               <a:lnSpc>
-                <a:spcPct val="110000"/>
+                <a:spcPct val="104000"/>
               </a:lnSpc>
             </a:pPr>
             <a:r>
-              <a:rPr sz="5070" b="1">
+              <a:rPr sz="6930" b="1">
                 <a:solidFill>
                   <a:srgbClr val="4F3433"/>
                 </a:solidFill>
@@ -3297,14 +3273,14 @@
       </p:sp>
       <p:sp>
         <p:nvSpPr>
-          <p:cNvPr id="10" name="small-line"/>
+          <p:cNvPr id="9" name="small-line"/>
           <p:cNvSpPr txBox="1"/>
           <p:nvPr/>
         </p:nvSpPr>
         <p:spPr>
           <a:xfrm>
-            <a:off x="626533" y="3302000"/>
-            <a:ext cx="6773333" cy="474133"/>
+            <a:off x="643467" y="4995333"/>
+            <a:ext cx="7620000" cy="592667"/>
           </a:xfrm>
           <a:prstGeom prst="rect">
             <a:avLst/>
@@ -3323,196 +3299,13 @@
               </a:lnSpc>
             </a:pPr>
             <a:r>
-              <a:rPr sz="2930" b="1">
+              <a:rPr sz="3729" b="1">
                 <a:solidFill>
                   <a:srgbClr val="156826"/>
                 </a:solidFill>
                 <a:latin typeface="Source Sans Pro"/>
               </a:rPr>
               <a:t>And who gets to decide?</a:t>
-            </a:r>
-          </a:p>
-        </p:txBody>
-      </p:sp>
-      <p:sp>
-        <p:nvSpPr>
-          <p:cNvPr id="11" name="question-1"/>
-          <p:cNvSpPr txBox="1"/>
-          <p:nvPr/>
-        </p:nvSpPr>
-        <p:spPr>
-          <a:xfrm>
-            <a:off x="609600" y="4148667"/>
-            <a:ext cx="7924800" cy="474133"/>
-          </a:xfrm>
-          <a:prstGeom prst="rect">
-            <a:avLst/>
-          </a:prstGeom>
-          <a:noFill/>
-        </p:spPr>
-        <p:txBody>
-          <a:bodyPr wrap="square" lIns="0" rIns="0" tIns="0" bIns="0">
-            <a:spAutoFit/>
-          </a:bodyPr>
-          <a:lstStyle/>
-          <a:p>
-            <a:pPr algn="l">
-              <a:lnSpc>
-                <a:spcPct val="112000"/>
-              </a:lnSpc>
-            </a:pPr>
-            <a:r>
-              <a:rPr sz="3329" b="1">
-                <a:solidFill>
-                  <a:srgbClr val="4F3433"/>
-                </a:solidFill>
-                <a:latin typeface="Montserrat"/>
-              </a:rPr>
-              <a:t>A destination </a:t>
-            </a:r>
-            <a:r>
-              <a:rPr sz="3329" b="1">
-                <a:solidFill>
-                  <a:srgbClr val="156826"/>
-                </a:solidFill>
-                <a:latin typeface="Montserrat"/>
-              </a:rPr>
-              <a:t>or a direction?</a:t>
-            </a:r>
-          </a:p>
-        </p:txBody>
-      </p:sp>
-      <p:sp>
-        <p:nvSpPr>
-          <p:cNvPr id="12" name="question-2"/>
-          <p:cNvSpPr txBox="1"/>
-          <p:nvPr/>
-        </p:nvSpPr>
-        <p:spPr>
-          <a:xfrm>
-            <a:off x="609600" y="4910667"/>
-            <a:ext cx="7924800" cy="948267"/>
-          </a:xfrm>
-          <a:prstGeom prst="rect">
-            <a:avLst/>
-          </a:prstGeom>
-          <a:noFill/>
-        </p:spPr>
-        <p:txBody>
-          <a:bodyPr wrap="square" lIns="0" rIns="0" tIns="0" bIns="0">
-            <a:spAutoFit/>
-          </a:bodyPr>
-          <a:lstStyle/>
-          <a:p>
-            <a:pPr algn="l">
-              <a:lnSpc>
-                <a:spcPct val="112000"/>
-              </a:lnSpc>
-            </a:pPr>
-            <a:r>
-              <a:rPr sz="3329" b="1">
-                <a:solidFill>
-                  <a:srgbClr val="4F3433"/>
-                </a:solidFill>
-                <a:latin typeface="Montserrat"/>
-              </a:rPr>
-              <a:t>A certified status </a:t>
-            </a:r>
-            <a:r>
-              <a:rPr sz="3329" b="1">
-                <a:solidFill>
-                  <a:srgbClr val="156826"/>
-                </a:solidFill>
-                <a:latin typeface="Montserrat"/>
-              </a:rPr>
-              <a:t>or a way of thinking?</a:t>
-            </a:r>
-          </a:p>
-        </p:txBody>
-      </p:sp>
-      <p:sp>
-        <p:nvSpPr>
-          <p:cNvPr id="13" name="question-3"/>
-          <p:cNvSpPr txBox="1"/>
-          <p:nvPr/>
-        </p:nvSpPr>
-        <p:spPr>
-          <a:xfrm>
-            <a:off x="609600" y="6146800"/>
-            <a:ext cx="7924800" cy="1422400"/>
-          </a:xfrm>
-          <a:prstGeom prst="rect">
-            <a:avLst/>
-          </a:prstGeom>
-          <a:noFill/>
-        </p:spPr>
-        <p:txBody>
-          <a:bodyPr wrap="square" lIns="0" rIns="0" tIns="0" bIns="0">
-            <a:spAutoFit/>
-          </a:bodyPr>
-          <a:lstStyle/>
-          <a:p>
-            <a:pPr algn="l">
-              <a:lnSpc>
-                <a:spcPct val="112000"/>
-              </a:lnSpc>
-            </a:pPr>
-            <a:r>
-              <a:rPr sz="3329" b="1">
-                <a:solidFill>
-                  <a:srgbClr val="4F3433"/>
-                </a:solidFill>
-                <a:latin typeface="Montserrat"/>
-              </a:rPr>
-              <a:t>A premium product, </a:t>
-            </a:r>
-            <a:r>
-              <a:rPr sz="3329" b="1">
-                <a:solidFill>
-                  <a:srgbClr val="156826"/>
-                </a:solidFill>
-                <a:latin typeface="Montserrat"/>
-              </a:rPr>
-              <a:t>or a standard everyone who works the land can reach?</a:t>
-            </a:r>
-          </a:p>
-        </p:txBody>
-      </p:sp>
-      <p:sp>
-        <p:nvSpPr>
-          <p:cNvPr id="14" name="cta"/>
-          <p:cNvSpPr txBox="1"/>
-          <p:nvPr/>
-        </p:nvSpPr>
-        <p:spPr>
-          <a:xfrm>
-            <a:off x="626533" y="7907867"/>
-            <a:ext cx="4741333" cy="931333"/>
-          </a:xfrm>
-          <a:prstGeom prst="rect">
-            <a:avLst/>
-          </a:prstGeom>
-          <a:noFill/>
-        </p:spPr>
-        <p:txBody>
-          <a:bodyPr wrap="square" lIns="0" rIns="0" tIns="0" bIns="0">
-            <a:spAutoFit/>
-          </a:bodyPr>
-          <a:lstStyle/>
-          <a:p>
-            <a:pPr algn="l">
-              <a:lnSpc>
-                <a:spcPct val="125000"/>
-              </a:lnSpc>
-            </a:pPr>
-            <a:r>
-              <a:rPr sz="2530" b="1">
-                <a:solidFill>
-                  <a:srgbClr val="4F3433"/>
-                </a:solidFill>
-                <a:latin typeface="Source Sans Pro"/>
-              </a:rPr>
-              <a:t>What does regenerative mean to you? Tell us in the comments.</a:t>
             </a:r>
           </a:p>
         </p:txBody>

</xml_diff>